<commit_message>
Docs: tell customers to enable each Job after creating it
Validation on the tenant showed a newly created Job can land disabled (no next-run
time, never fires — tracker stays empty, Scan no-ops). Add an explicit 'enable each
Job' step to all four docs: README minimal-install, Playbooks/README job setup,
Customer Guide 10.5 + 13.2, and the Test Guide (minimal-import slide + Test 9).

Co-Authored-By: Claude Fable 5 <noreply@anthropic.com>
</commit_message>
<xml_diff>
--- a/docs/KOI_Content_Pack_Test_Guide.pptx
+++ b/docs/KOI_Content_Pack_Test_Guide.pptx
@@ -13000,7 +13000,7 @@
                 <a:ea typeface="Calibri" pitchFamily="34" charset="-122"/>
                 <a:cs typeface="Calibri" pitchFamily="34" charset="-120"/>
               </a:rPr>
-              <a:t>Two jobs: Refresh builds the tracker, Scan runs the due endpoints — run Refresh once before the first Scan. Mark-on-dispatch means a poll timeout logs STILL RUNNING and never emails; a SKIPPED entry is not a failure.</a:t>
+              <a:t>Two jobs (enable both after creating them): Refresh builds the tracker, Scan runs the due endpoints — run Refresh once before the first Scan. Mark-on-dispatch means a poll timeout logs STILL RUNNING and never emails; a SKIPPED entry is not a failure.</a:t>
             </a:r>
             <a:endParaRPr lang="en-US" sz="1050" dirty="0"/>
           </a:p>
@@ -20665,7 +20665,7 @@
                 <a:ea typeface="Calibri" pitchFamily="34" charset="-122"/>
                 <a:cs typeface="Calibri" pitchFamily="34" charset="-120"/>
               </a:rPr>
-              <a:t>Create the JSON List Koi Script Runner (Object Setup → Lists). Then two Time-triggered Jobs: Scan → Koi Unified - Script Runner (frequent, e.g. 10 min); Refresh → Koi Unified - Refresh Tracker (hourly). The per-scope tracker Lists auto-create on the first Refresh. You still need the built-in Core REST API integration enabled — no KOI key, no KOI instance, no rules or dashboard.</a:t>
+              <a:t>Create the JSON List Koi Script Runner (Object Setup → Lists). Then two Time-triggered Jobs: Scan → Koi Unified - Script Runner (e.g. 10 min); Refresh → Koi Unified - Refresh Tracker (hourly). Enable both — a new Job can be created disabled. The tracker Lists auto-create on the first Refresh. Also enable the built-in Core REST API integration — no KOI key, instance, rules or dashboard.</a:t>
             </a:r>
             <a:endParaRPr lang="en-US" sz="1000" dirty="0"/>
           </a:p>

</xml_diff>

<commit_message>
Drop the explanatory asides from the upload steps
The upload steps carried asides that came out of debugging rather than out of the task:
what the reader would see inside the file, which other file not to pick, and why that
other file looks the way it does. None of it is a step, and the guide is public. The
instruction is now the one path to import; the source yml keeps a short factual header
for anyone reading the pack itself.

Added a check that fails when a guide prints a path that does not exist in its own repo.
The two packs sit at different depths — this one is its own repo root, the marketplace
pack lives under Packs/KoiContentExtension/ — so a path copied between the decks
resolves in one and not the other, which is invisible until a reader goes looking.

Co-Authored-By: Claude Fable 5 <noreply@anthropic.com>
</commit_message>
<xml_diff>
--- a/docs/KOI_Content_Pack_Test_Guide.pptx
+++ b/docs/KOI_Content_Pack_Test_Guide.pptx
@@ -9544,7 +9544,7 @@
                 <a:ea typeface="Calibri" pitchFamily="34" charset="-122"/>
                 <a:cs typeface="Calibri" pitchFamily="34" charset="-120"/>
               </a:rPr>
-              <a:t>KoiScanTracker — an automation, not a playbook. Ours, and different from the KOI deployment script opposite. Manual upload takes exactly one file: dist/automation-KoiScanTracker.yml</a:t>
+              <a:t>KoiScanTracker — an automation, not a playbook, and separate from the KOI deployment script opposite. Manual import takes one file: dist/automation-KoiScanTracker.yml</a:t>
             </a:r>
             <a:endParaRPr lang="en-US" sz="1050" dirty="0"/>
           </a:p>
@@ -10162,7 +10162,7 @@
                 <a:ea typeface="Calibri" pitchFamily="34" charset="-122"/>
                 <a:cs typeface="Calibri" pitchFamily="34" charset="-120"/>
               </a:rPr>
-              <a:t>Automation → Scripts → Import → dist/automation-KoiScanTracker.yml. Open it first and you will see the Python inside it.</a:t>
+              <a:t>Automation → Scripts → Import → dist/automation-KoiScanTracker.yml</a:t>
             </a:r>
             <a:endParaRPr lang="en-US" sz="1150" dirty="0"/>
           </a:p>
@@ -10243,7 +10243,7 @@
                 <a:ea typeface="Calibri" pitchFamily="34" charset="-122"/>
                 <a:cs typeface="Calibri" pitchFamily="34" charset="-120"/>
               </a:rPr>
-              <a:t>Not Scripts/KoiScanTracker/KoiScanTracker.yml — that file reads script: '-' on purpose and would import an empty automation.</a:t>
+              <a:t>Settings → Object Setup → Lists → New List, type JSON, named exactly Koi Script Runner. Paste the block from Lists/README.md.</a:t>
             </a:r>
             <a:endParaRPr lang="en-US" sz="1150" dirty="0"/>
           </a:p>
@@ -10297,87 +10297,6 @@
         <p:spPr>
           <a:xfrm>
             <a:off x="1152144" y="6053328"/>
-            <a:ext cx="10149840" cy="246888"/>
-          </a:xfrm>
-          <a:prstGeom prst="rect">
-            <a:avLst/>
-          </a:prstGeom>
-          <a:noFill/>
-          <a:ln/>
-        </p:spPr>
-        <p:txBody>
-          <a:bodyPr wrap="square" lIns="0" tIns="0" rIns="0" bIns="0" rtlCol="0" anchor="t"/>
-          <a:lstStyle/>
-          <a:p>
-            <a:pPr indent="0" marL="0">
-              <a:lnSpc>
-                <a:spcPts val="1500"/>
-              </a:lnSpc>
-              <a:buNone/>
-            </a:pPr>
-            <a:r>
-              <a:rPr lang="en-US" sz="1150" dirty="0">
-                <a:solidFill>
-                  <a:srgbClr val="B4B7BD"/>
-                </a:solidFill>
-                <a:latin typeface="Calibri" pitchFamily="34" charset="0"/>
-                <a:ea typeface="Calibri" pitchFamily="34" charset="-122"/>
-                <a:cs typeface="Calibri" pitchFamily="34" charset="-120"/>
-              </a:rPr>
-              <a:t>Settings → Object Setup → Lists → New List, type JSON, named exactly Koi Script Runner. Paste the block from Lists/README.md.</a:t>
-            </a:r>
-            <a:endParaRPr lang="en-US" sz="1150" dirty="0"/>
-          </a:p>
-        </p:txBody>
-      </p:sp>
-      <p:sp>
-        <p:nvSpPr>
-          <p:cNvPr id="34" name="Text 32"/>
-          <p:cNvSpPr/>
-          <p:nvPr/>
-        </p:nvSpPr>
-        <p:spPr>
-          <a:xfrm>
-            <a:off x="859536" y="6382512"/>
-            <a:ext cx="219456" cy="256032"/>
-          </a:xfrm>
-          <a:prstGeom prst="rect">
-            <a:avLst/>
-          </a:prstGeom>
-          <a:noFill/>
-          <a:ln/>
-        </p:spPr>
-        <p:txBody>
-          <a:bodyPr wrap="square" lIns="0" tIns="0" rIns="0" bIns="0" rtlCol="0" anchor="t"/>
-          <a:lstStyle/>
-          <a:p>
-            <a:pPr indent="0" marL="0">
-              <a:buNone/>
-            </a:pPr>
-            <a:r>
-              <a:rPr lang="en-US" sz="1150" b="1" dirty="0">
-                <a:solidFill>
-                  <a:srgbClr val="E8551F"/>
-                </a:solidFill>
-                <a:latin typeface="Calibri" pitchFamily="34" charset="0"/>
-                <a:ea typeface="Calibri" pitchFamily="34" charset="-122"/>
-                <a:cs typeface="Calibri" pitchFamily="34" charset="-120"/>
-              </a:rPr>
-              <a:t>6</a:t>
-            </a:r>
-            <a:endParaRPr lang="en-US" sz="1150" dirty="0"/>
-          </a:p>
-        </p:txBody>
-      </p:sp>
-      <p:sp>
-        <p:nvSpPr>
-          <p:cNvPr id="35" name="Text 33"/>
-          <p:cNvSpPr/>
-          <p:nvPr/>
-        </p:nvSpPr>
-        <p:spPr>
-          <a:xfrm>
-            <a:off x="1152144" y="6382512"/>
             <a:ext cx="10149840" cy="246888"/>
           </a:xfrm>
           <a:prstGeom prst="rect">

</xml_diff>